<commit_message>
feat(text): add Font.strikethrough property (#574)
Introduce the MSO_TEXT_STRIKE_TYPE enumeration (alias MSO_STRIKE) and
wire the `a:rPr/@strike` attribute onto CT_TextCharacterProperties.
The new Font.strikethrough property mirrors Font.bold/italic/underline:
True/False for single-strike/no-strike, None to inherit, and
MSO_STRIKE.DOUBLE_LINE for the tri-state double-strike value.

Co-Authored-By: Claude Opus 4.7 (1M context) <noreply@anthropic.com>
</commit_message>
<xml_diff>
--- a/features/steps/test_files/txt-font-props.pptx
+++ b/features/steps/test_files/txt-font-props.pptx
@@ -10,6 +10,7 @@
     <p:sldId id="258" r:id="rId4"/>
     <p:sldId id="259" r:id="rId5"/>
     <p:sldId id="260" r:id="rId6"/>
+    <p:sldId id="261" r:id="rId12"/>
   </p:sldIdLst>
   <p:sldSz cx="9144000" cy="6858000" type="screen4x3"/>
   <p:notesSz cx="6858000" cy="9144000"/>
@@ -897,6 +898,140 @@
         <p14:creationId xmlns:p14="http://schemas.microsoft.com/office/powerpoint/2010/main" val="2695938300"/>
       </p:ext>
     </p:extLst>
+  </p:cSld>
+  <p:clrMapOvr>
+    <a:masterClrMapping/>
+  </p:clrMapOvr>
+</p:sld>
+</file>
+
+<file path=ppt/slides/slide6.xml><?xml version="1.0" encoding="utf-8"?>
+<p:sld xmlns:a="http://schemas.openxmlformats.org/drawingml/2006/main" xmlns:p="http://schemas.openxmlformats.org/presentationml/2006/main" xmlns:r="http://schemas.openxmlformats.org/officeDocument/2006/relationships">
+  <p:cSld>
+    <p:spTree>
+      <p:nvGrpSpPr>
+        <p:cNvPr id="1" name=""/>
+        <p:cNvGrpSpPr/>
+        <p:nvPr/>
+      </p:nvGrpSpPr>
+      <p:grpSpPr/>
+      <p:sp>
+        <p:nvSpPr>
+          <p:cNvPr id="2" name="TextBox 1"/>
+          <p:cNvSpPr txBox="1"/>
+          <p:nvPr/>
+        </p:nvSpPr>
+        <p:spPr>
+          <a:xfrm>
+            <a:off x="914400" y="457200"/>
+            <a:ext cx="3657600" cy="457200"/>
+          </a:xfrm>
+          <a:prstGeom prst="rect">
+            <a:avLst/>
+          </a:prstGeom>
+          <a:noFill/>
+        </p:spPr>
+        <p:txBody>
+          <a:bodyPr wrap="none">
+            <a:spAutoFit/>
+          </a:bodyPr>
+          <a:lstStyle/>
+          <a:p>
+            <a:r>
+              <a:rPr strike="sngStrike"/>
+              <a:t>Strikethrough on</a:t>
+            </a:r>
+          </a:p>
+        </p:txBody>
+      </p:sp>
+      <p:sp>
+        <p:nvSpPr>
+          <p:cNvPr id="3" name="TextBox 2"/>
+          <p:cNvSpPr txBox="1"/>
+          <p:nvPr/>
+        </p:nvSpPr>
+        <p:spPr>
+          <a:xfrm>
+            <a:off x="914400" y="1371600"/>
+            <a:ext cx="3657600" cy="457200"/>
+          </a:xfrm>
+          <a:prstGeom prst="rect">
+            <a:avLst/>
+          </a:prstGeom>
+          <a:noFill/>
+        </p:spPr>
+        <p:txBody>
+          <a:bodyPr wrap="none">
+            <a:spAutoFit/>
+          </a:bodyPr>
+          <a:lstStyle/>
+          <a:p>
+            <a:r>
+              <a:rPr strike="noStrike"/>
+              <a:t>Strikethrough off</a:t>
+            </a:r>
+          </a:p>
+        </p:txBody>
+      </p:sp>
+      <p:sp>
+        <p:nvSpPr>
+          <p:cNvPr id="4" name="TextBox 3"/>
+          <p:cNvSpPr txBox="1"/>
+          <p:nvPr/>
+        </p:nvSpPr>
+        <p:spPr>
+          <a:xfrm>
+            <a:off x="914400" y="2286000"/>
+            <a:ext cx="3657600" cy="457200"/>
+          </a:xfrm>
+          <a:prstGeom prst="rect">
+            <a:avLst/>
+          </a:prstGeom>
+          <a:noFill/>
+        </p:spPr>
+        <p:txBody>
+          <a:bodyPr wrap="none">
+            <a:spAutoFit/>
+          </a:bodyPr>
+          <a:lstStyle/>
+          <a:p>
+            <a:r>
+              <a:rPr/>
+              <a:t>Strikethrough to inherit</a:t>
+            </a:r>
+          </a:p>
+        </p:txBody>
+      </p:sp>
+      <p:sp>
+        <p:nvSpPr>
+          <p:cNvPr id="5" name="TextBox 4"/>
+          <p:cNvSpPr txBox="1"/>
+          <p:nvPr/>
+        </p:nvSpPr>
+        <p:spPr>
+          <a:xfrm>
+            <a:off x="914400" y="3200400"/>
+            <a:ext cx="3657600" cy="457200"/>
+          </a:xfrm>
+          <a:prstGeom prst="rect">
+            <a:avLst/>
+          </a:prstGeom>
+          <a:noFill/>
+        </p:spPr>
+        <p:txBody>
+          <a:bodyPr wrap="none">
+            <a:spAutoFit/>
+          </a:bodyPr>
+          <a:lstStyle/>
+          <a:p>
+            <a:r>
+              <a:rPr strike="dblStrike"/>
+              <a:t>Strikethrough to DOUBLE_LINE</a:t>
+            </a:r>
+          </a:p>
+        </p:txBody>
+      </p:sp>
+    </p:spTree>
   </p:cSld>
   <p:clrMapOvr>
     <a:masterClrMapping/>

</xml_diff>